<commit_message>
+ 1 pres slide
</commit_message>
<xml_diff>
--- a/results/pres.pptx
+++ b/results/pres.pptx
@@ -20,6 +20,7 @@
     <p:sldId id="275" r:id="rId14"/>
     <p:sldId id="271" r:id="rId15"/>
     <p:sldId id="272" r:id="rId16"/>
+    <p:sldId id="276" r:id="rId17"/>
   </p:sldIdLst>
   <p:sldSz cx="12192000" cy="6858000"/>
   <p:notesSz cx="6858000" cy="9144000"/>
@@ -4039,6 +4040,95 @@
 </p:sld>
 </file>
 
+<file path=ppt/slides/slide16.xml><?xml version="1.0" encoding="utf-8"?>
+<p:sld xmlns:a="http://schemas.openxmlformats.org/drawingml/2006/main" xmlns:r="http://schemas.openxmlformats.org/officeDocument/2006/relationships" xmlns:p="http://schemas.openxmlformats.org/presentationml/2006/main">
+  <p:cSld>
+    <p:spTree>
+      <p:nvGrpSpPr>
+        <p:cNvPr id="1" name=""/>
+        <p:cNvGrpSpPr/>
+        <p:nvPr/>
+      </p:nvGrpSpPr>
+      <p:grpSpPr>
+        <a:xfrm>
+          <a:off x="0" y="0"/>
+          <a:ext cx="0" cy="0"/>
+          <a:chOff x="0" y="0"/>
+          <a:chExt cx="0" cy="0"/>
+        </a:xfrm>
+      </p:grpSpPr>
+      <p:sp>
+        <p:nvSpPr>
+          <p:cNvPr id="2" name="Title 1">
+            <a:extLst>
+              <a:ext uri="{FF2B5EF4-FFF2-40B4-BE49-F238E27FC236}">
+                <a16:creationId xmlns:a16="http://schemas.microsoft.com/office/drawing/2014/main" id="{E462399C-D3D2-1C76-C99D-DE975D803ECC}"/>
+              </a:ext>
+            </a:extLst>
+          </p:cNvPr>
+          <p:cNvSpPr>
+            <a:spLocks noGrp="1"/>
+          </p:cNvSpPr>
+          <p:nvPr>
+            <p:ph type="title"/>
+          </p:nvPr>
+        </p:nvSpPr>
+        <p:spPr/>
+        <p:txBody>
+          <a:bodyPr/>
+          <a:lstStyle/>
+          <a:p>
+            <a:r>
+              <a:rPr lang="ru-RU" dirty="0"/>
+              <a:t>Общие графики</a:t>
+            </a:r>
+            <a:endParaRPr lang="en-US" dirty="0"/>
+          </a:p>
+        </p:txBody>
+      </p:sp>
+      <p:pic>
+        <p:nvPicPr>
+          <p:cNvPr id="4" name="Picture 3">
+            <a:extLst>
+              <a:ext uri="{FF2B5EF4-FFF2-40B4-BE49-F238E27FC236}">
+                <a16:creationId xmlns:a16="http://schemas.microsoft.com/office/drawing/2014/main" id="{248234BF-D57F-D595-6233-0320370AF913}"/>
+              </a:ext>
+            </a:extLst>
+          </p:cNvPr>
+          <p:cNvPicPr>
+            <a:picLocks noChangeAspect="1"/>
+          </p:cNvPicPr>
+          <p:nvPr/>
+        </p:nvPicPr>
+        <p:blipFill>
+          <a:blip r:embed="rId2"/>
+          <a:stretch>
+            <a:fillRect/>
+          </a:stretch>
+        </p:blipFill>
+        <p:spPr>
+          <a:xfrm>
+            <a:off x="1134643" y="1373559"/>
+            <a:ext cx="9922714" cy="5119316"/>
+          </a:xfrm>
+          <a:prstGeom prst="rect">
+            <a:avLst/>
+          </a:prstGeom>
+        </p:spPr>
+      </p:pic>
+    </p:spTree>
+    <p:extLst>
+      <p:ext uri="{BB962C8B-B14F-4D97-AF65-F5344CB8AC3E}">
+        <p14:creationId xmlns:p14="http://schemas.microsoft.com/office/powerpoint/2010/main" val="801357139"/>
+      </p:ext>
+    </p:extLst>
+  </p:cSld>
+  <p:clrMapOvr>
+    <a:masterClrMapping/>
+  </p:clrMapOvr>
+</p:sld>
+</file>
+
 <file path=ppt/slides/slide2.xml><?xml version="1.0" encoding="utf-8"?>
 <p:sld xmlns:a="http://schemas.openxmlformats.org/drawingml/2006/main" xmlns:r="http://schemas.openxmlformats.org/officeDocument/2006/relationships" xmlns:p="http://schemas.openxmlformats.org/presentationml/2006/main">
   <p:cSld>

</xml_diff>

<commit_message>
+ results on test files
</commit_message>
<xml_diff>
--- a/results/pres.pptx
+++ b/results/pres.pptx
@@ -13,14 +13,16 @@
     <p:sldId id="264" r:id="rId7"/>
     <p:sldId id="262" r:id="rId8"/>
     <p:sldId id="265" r:id="rId9"/>
-    <p:sldId id="266" r:id="rId10"/>
-    <p:sldId id="267" r:id="rId11"/>
-    <p:sldId id="268" r:id="rId12"/>
-    <p:sldId id="269" r:id="rId13"/>
-    <p:sldId id="275" r:id="rId14"/>
-    <p:sldId id="271" r:id="rId15"/>
-    <p:sldId id="272" r:id="rId16"/>
-    <p:sldId id="276" r:id="rId17"/>
+    <p:sldId id="278" r:id="rId10"/>
+    <p:sldId id="277" r:id="rId11"/>
+    <p:sldId id="266" r:id="rId12"/>
+    <p:sldId id="267" r:id="rId13"/>
+    <p:sldId id="268" r:id="rId14"/>
+    <p:sldId id="269" r:id="rId15"/>
+    <p:sldId id="275" r:id="rId16"/>
+    <p:sldId id="271" r:id="rId17"/>
+    <p:sldId id="272" r:id="rId18"/>
+    <p:sldId id="276" r:id="rId19"/>
   </p:sldIdLst>
   <p:sldSz cx="12192000" cy="6858000"/>
   <p:notesSz cx="6858000" cy="9144000"/>
@@ -119,6 +121,11 @@
       </a:defRPr>
     </a:lvl9pPr>
   </p:defaultTextStyle>
+  <p:extLst>
+    <p:ext uri="{EFAFB233-063F-42B5-8137-9DF3F51BA10A}">
+      <p15:sldGuideLst xmlns:p15="http://schemas.microsoft.com/office/powerpoint/2012/main"/>
+    </p:ext>
+  </p:extLst>
 </p:presentation>
 </file>
 
@@ -269,7 +276,7 @@
           <a:p>
             <a:fld id="{954D5CCF-EDB3-1944-BB31-7ADB8F2E1A0A}" type="datetimeFigureOut">
               <a:rPr lang="en-US" smtClean="0"/>
-              <a:t>5/25/25</a:t>
+              <a:t>5/30/25</a:t>
             </a:fld>
             <a:endParaRPr lang="en-US"/>
           </a:p>
@@ -467,7 +474,7 @@
           <a:p>
             <a:fld id="{954D5CCF-EDB3-1944-BB31-7ADB8F2E1A0A}" type="datetimeFigureOut">
               <a:rPr lang="en-US" smtClean="0"/>
-              <a:t>5/25/25</a:t>
+              <a:t>5/30/25</a:t>
             </a:fld>
             <a:endParaRPr lang="en-US"/>
           </a:p>
@@ -675,7 +682,7 @@
           <a:p>
             <a:fld id="{954D5CCF-EDB3-1944-BB31-7ADB8F2E1A0A}" type="datetimeFigureOut">
               <a:rPr lang="en-US" smtClean="0"/>
-              <a:t>5/25/25</a:t>
+              <a:t>5/30/25</a:t>
             </a:fld>
             <a:endParaRPr lang="en-US"/>
           </a:p>
@@ -873,7 +880,7 @@
           <a:p>
             <a:fld id="{954D5CCF-EDB3-1944-BB31-7ADB8F2E1A0A}" type="datetimeFigureOut">
               <a:rPr lang="en-US" smtClean="0"/>
-              <a:t>5/25/25</a:t>
+              <a:t>5/30/25</a:t>
             </a:fld>
             <a:endParaRPr lang="en-US"/>
           </a:p>
@@ -1148,7 +1155,7 @@
           <a:p>
             <a:fld id="{954D5CCF-EDB3-1944-BB31-7ADB8F2E1A0A}" type="datetimeFigureOut">
               <a:rPr lang="en-US" smtClean="0"/>
-              <a:t>5/25/25</a:t>
+              <a:t>5/30/25</a:t>
             </a:fld>
             <a:endParaRPr lang="en-US"/>
           </a:p>
@@ -1413,7 +1420,7 @@
           <a:p>
             <a:fld id="{954D5CCF-EDB3-1944-BB31-7ADB8F2E1A0A}" type="datetimeFigureOut">
               <a:rPr lang="en-US" smtClean="0"/>
-              <a:t>5/25/25</a:t>
+              <a:t>5/30/25</a:t>
             </a:fld>
             <a:endParaRPr lang="en-US"/>
           </a:p>
@@ -1825,7 +1832,7 @@
           <a:p>
             <a:fld id="{954D5CCF-EDB3-1944-BB31-7ADB8F2E1A0A}" type="datetimeFigureOut">
               <a:rPr lang="en-US" smtClean="0"/>
-              <a:t>5/25/25</a:t>
+              <a:t>5/30/25</a:t>
             </a:fld>
             <a:endParaRPr lang="en-US"/>
           </a:p>
@@ -1966,7 +1973,7 @@
           <a:p>
             <a:fld id="{954D5CCF-EDB3-1944-BB31-7ADB8F2E1A0A}" type="datetimeFigureOut">
               <a:rPr lang="en-US" smtClean="0"/>
-              <a:t>5/25/25</a:t>
+              <a:t>5/30/25</a:t>
             </a:fld>
             <a:endParaRPr lang="en-US"/>
           </a:p>
@@ -2079,7 +2086,7 @@
           <a:p>
             <a:fld id="{954D5CCF-EDB3-1944-BB31-7ADB8F2E1A0A}" type="datetimeFigureOut">
               <a:rPr lang="en-US" smtClean="0"/>
-              <a:t>5/25/25</a:t>
+              <a:t>5/30/25</a:t>
             </a:fld>
             <a:endParaRPr lang="en-US"/>
           </a:p>
@@ -2390,7 +2397,7 @@
           <a:p>
             <a:fld id="{954D5CCF-EDB3-1944-BB31-7ADB8F2E1A0A}" type="datetimeFigureOut">
               <a:rPr lang="en-US" smtClean="0"/>
-              <a:t>5/25/25</a:t>
+              <a:t>5/30/25</a:t>
             </a:fld>
             <a:endParaRPr lang="en-US"/>
           </a:p>
@@ -2678,7 +2685,7 @@
           <a:p>
             <a:fld id="{954D5CCF-EDB3-1944-BB31-7ADB8F2E1A0A}" type="datetimeFigureOut">
               <a:rPr lang="en-US" smtClean="0"/>
-              <a:t>5/25/25</a:t>
+              <a:t>5/30/25</a:t>
             </a:fld>
             <a:endParaRPr lang="en-US"/>
           </a:p>
@@ -2919,7 +2926,7 @@
           <a:p>
             <a:fld id="{954D5CCF-EDB3-1944-BB31-7ADB8F2E1A0A}" type="datetimeFigureOut">
               <a:rPr lang="en-US" smtClean="0"/>
-              <a:t>5/25/25</a:t>
+              <a:t>5/30/25</a:t>
             </a:fld>
             <a:endParaRPr lang="en-US"/>
           </a:p>
@@ -3429,6 +3436,153 @@
           <p:cNvPr id="2" name="Title 1">
             <a:extLst>
               <a:ext uri="{FF2B5EF4-FFF2-40B4-BE49-F238E27FC236}">
+                <a16:creationId xmlns:a16="http://schemas.microsoft.com/office/drawing/2014/main" id="{F5ECD825-C439-7039-23E6-60350D21DEAB}"/>
+              </a:ext>
+            </a:extLst>
+          </p:cNvPr>
+          <p:cNvSpPr>
+            <a:spLocks noGrp="1"/>
+          </p:cNvSpPr>
+          <p:nvPr>
+            <p:ph type="title"/>
+          </p:nvPr>
+        </p:nvSpPr>
+        <p:spPr/>
+        <p:txBody>
+          <a:bodyPr/>
+          <a:lstStyle/>
+          <a:p>
+            <a:r>
+              <a:rPr lang="en-US" dirty="0"/>
+              <a:t>SC, graph_8</a:t>
+            </a:r>
+          </a:p>
+        </p:txBody>
+      </p:sp>
+      <p:pic>
+        <p:nvPicPr>
+          <p:cNvPr id="4" name="Picture 3">
+            <a:extLst>
+              <a:ext uri="{FF2B5EF4-FFF2-40B4-BE49-F238E27FC236}">
+                <a16:creationId xmlns:a16="http://schemas.microsoft.com/office/drawing/2014/main" id="{A3A29C8B-8522-B51D-F23A-C5AFDE628FDB}"/>
+              </a:ext>
+            </a:extLst>
+          </p:cNvPr>
+          <p:cNvPicPr>
+            <a:picLocks noChangeAspect="1"/>
+          </p:cNvPicPr>
+          <p:nvPr/>
+        </p:nvPicPr>
+        <p:blipFill>
+          <a:blip r:embed="rId2"/>
+          <a:stretch>
+            <a:fillRect/>
+          </a:stretch>
+        </p:blipFill>
+        <p:spPr>
+          <a:xfrm>
+            <a:off x="0" y="2279694"/>
+            <a:ext cx="12192000" cy="3233791"/>
+          </a:xfrm>
+          <a:prstGeom prst="rect">
+            <a:avLst/>
+          </a:prstGeom>
+        </p:spPr>
+      </p:pic>
+    </p:spTree>
+    <p:extLst>
+      <p:ext uri="{BB962C8B-B14F-4D97-AF65-F5344CB8AC3E}">
+        <p14:creationId xmlns:p14="http://schemas.microsoft.com/office/powerpoint/2010/main" val="4016728384"/>
+      </p:ext>
+    </p:extLst>
+  </p:cSld>
+  <p:clrMapOvr>
+    <a:masterClrMapping/>
+  </p:clrMapOvr>
+</p:sld>
+</file>
+
+<file path=ppt/slides/slide11.xml><?xml version="1.0" encoding="utf-8"?>
+<p:sld xmlns:a="http://schemas.openxmlformats.org/drawingml/2006/main" xmlns:r="http://schemas.openxmlformats.org/officeDocument/2006/relationships" xmlns:p="http://schemas.openxmlformats.org/presentationml/2006/main">
+  <p:cSld>
+    <p:spTree>
+      <p:nvGrpSpPr>
+        <p:cNvPr id="1" name=""/>
+        <p:cNvGrpSpPr/>
+        <p:nvPr/>
+      </p:nvGrpSpPr>
+      <p:grpSpPr>
+        <a:xfrm>
+          <a:off x="0" y="0"/>
+          <a:ext cx="0" cy="0"/>
+          <a:chOff x="0" y="0"/>
+          <a:chExt cx="0" cy="0"/>
+        </a:xfrm>
+      </p:grpSpPr>
+      <p:sp>
+        <p:nvSpPr>
+          <p:cNvPr id="2" name="Title 1">
+            <a:extLst>
+              <a:ext uri="{FF2B5EF4-FFF2-40B4-BE49-F238E27FC236}">
+                <a16:creationId xmlns:a16="http://schemas.microsoft.com/office/drawing/2014/main" id="{7E75FED4-BA3D-0044-55EA-1518683CD07B}"/>
+              </a:ext>
+            </a:extLst>
+          </p:cNvPr>
+          <p:cNvSpPr>
+            <a:spLocks noGrp="1"/>
+          </p:cNvSpPr>
+          <p:nvPr>
+            <p:ph type="title"/>
+          </p:nvPr>
+        </p:nvSpPr>
+        <p:spPr/>
+        <p:txBody>
+          <a:bodyPr/>
+          <a:lstStyle/>
+          <a:p>
+            <a:r>
+              <a:rPr lang="ru-RU" dirty="0"/>
+              <a:t>Выводы</a:t>
+            </a:r>
+            <a:endParaRPr lang="en-US" dirty="0"/>
+          </a:p>
+        </p:txBody>
+      </p:sp>
+    </p:spTree>
+    <p:extLst>
+      <p:ext uri="{BB962C8B-B14F-4D97-AF65-F5344CB8AC3E}">
+        <p14:creationId xmlns:p14="http://schemas.microsoft.com/office/powerpoint/2010/main" val="1017558136"/>
+      </p:ext>
+    </p:extLst>
+  </p:cSld>
+  <p:clrMapOvr>
+    <a:masterClrMapping/>
+  </p:clrMapOvr>
+</p:sld>
+</file>
+
+<file path=ppt/slides/slide12.xml><?xml version="1.0" encoding="utf-8"?>
+<p:sld xmlns:a="http://schemas.openxmlformats.org/drawingml/2006/main" xmlns:r="http://schemas.openxmlformats.org/officeDocument/2006/relationships" xmlns:p="http://schemas.openxmlformats.org/presentationml/2006/main">
+  <p:cSld>
+    <p:spTree>
+      <p:nvGrpSpPr>
+        <p:cNvPr id="1" name=""/>
+        <p:cNvGrpSpPr/>
+        <p:nvPr/>
+      </p:nvGrpSpPr>
+      <p:grpSpPr>
+        <a:xfrm>
+          <a:off x="0" y="0"/>
+          <a:ext cx="0" cy="0"/>
+          <a:chOff x="0" y="0"/>
+          <a:chExt cx="0" cy="0"/>
+        </a:xfrm>
+      </p:grpSpPr>
+      <p:sp>
+        <p:nvSpPr>
+          <p:cNvPr id="2" name="Title 1">
+            <a:extLst>
+              <a:ext uri="{FF2B5EF4-FFF2-40B4-BE49-F238E27FC236}">
                 <a16:creationId xmlns:a16="http://schemas.microsoft.com/office/drawing/2014/main" id="{ADBFFA0D-F416-5165-C864-9DAC1A68A858}"/>
               </a:ext>
             </a:extLst>
@@ -3509,7 +3663,7 @@
 </p:sld>
 </file>
 
-<file path=ppt/slides/slide11.xml><?xml version="1.0" encoding="utf-8"?>
+<file path=ppt/slides/slide13.xml><?xml version="1.0" encoding="utf-8"?>
 <p:sld xmlns:a="http://schemas.openxmlformats.org/drawingml/2006/main" xmlns:r="http://schemas.openxmlformats.org/officeDocument/2006/relationships" xmlns:p="http://schemas.openxmlformats.org/presentationml/2006/main">
   <p:cSld>
     <p:spTree>
@@ -3630,7 +3784,7 @@
 </p:sld>
 </file>
 
-<file path=ppt/slides/slide12.xml><?xml version="1.0" encoding="utf-8"?>
+<file path=ppt/slides/slide14.xml><?xml version="1.0" encoding="utf-8"?>
 <p:sld xmlns:a="http://schemas.openxmlformats.org/drawingml/2006/main" xmlns:r="http://schemas.openxmlformats.org/officeDocument/2006/relationships" xmlns:p="http://schemas.openxmlformats.org/presentationml/2006/main">
   <p:cSld>
     <p:spTree>
@@ -3735,7 +3889,7 @@
 </p:sld>
 </file>
 
-<file path=ppt/slides/slide13.xml><?xml version="1.0" encoding="utf-8"?>
+<file path=ppt/slides/slide15.xml><?xml version="1.0" encoding="utf-8"?>
 <p:sld xmlns:a="http://schemas.openxmlformats.org/drawingml/2006/main" xmlns:r="http://schemas.openxmlformats.org/officeDocument/2006/relationships" xmlns:p="http://schemas.openxmlformats.org/presentationml/2006/main">
   <p:cSld>
     <p:spTree>
@@ -3775,7 +3929,7 @@
           <a:p>
             <a:r>
               <a:rPr lang="ru-RU" dirty="0"/>
-              <a:t>Общие графики</a:t>
+              <a:t>Общие графики точности</a:t>
             </a:r>
             <a:endParaRPr lang="en-US" dirty="0"/>
           </a:p>
@@ -3824,7 +3978,7 @@
 </p:sld>
 </file>
 
-<file path=ppt/slides/slide14.xml><?xml version="1.0" encoding="utf-8"?>
+<file path=ppt/slides/slide16.xml><?xml version="1.0" encoding="utf-8"?>
 <p:sld xmlns:a="http://schemas.openxmlformats.org/drawingml/2006/main" xmlns:r="http://schemas.openxmlformats.org/officeDocument/2006/relationships" xmlns:p="http://schemas.openxmlformats.org/presentationml/2006/main">
   <p:cSld>
     <p:spTree>
@@ -3932,7 +4086,7 @@
 </p:sld>
 </file>
 
-<file path=ppt/slides/slide15.xml><?xml version="1.0" encoding="utf-8"?>
+<file path=ppt/slides/slide17.xml><?xml version="1.0" encoding="utf-8"?>
 <p:sld xmlns:a="http://schemas.openxmlformats.org/drawingml/2006/main" xmlns:r="http://schemas.openxmlformats.org/officeDocument/2006/relationships" xmlns:p="http://schemas.openxmlformats.org/presentationml/2006/main">
   <p:cSld>
     <p:spTree>
@@ -4040,7 +4194,7 @@
 </p:sld>
 </file>
 
-<file path=ppt/slides/slide16.xml><?xml version="1.0" encoding="utf-8"?>
+<file path=ppt/slides/slide18.xml><?xml version="1.0" encoding="utf-8"?>
 <p:sld xmlns:a="http://schemas.openxmlformats.org/drawingml/2006/main" xmlns:r="http://schemas.openxmlformats.org/officeDocument/2006/relationships" xmlns:p="http://schemas.openxmlformats.org/presentationml/2006/main">
   <p:cSld>
     <p:spTree>
@@ -4081,6 +4235,14 @@
             <a:r>
               <a:rPr lang="ru-RU" dirty="0"/>
               <a:t>Общие графики</a:t>
+            </a:r>
+            <a:r>
+              <a:rPr lang="en-US" dirty="0"/>
+              <a:t> </a:t>
+            </a:r>
+            <a:r>
+              <a:rPr lang="ru-RU" dirty="0"/>
+              <a:t>времени</a:t>
             </a:r>
             <a:endParaRPr lang="en-US" dirty="0"/>
           </a:p>
@@ -4788,7 +4950,7 @@
           <p:cNvPr id="2" name="Title 1">
             <a:extLst>
               <a:ext uri="{FF2B5EF4-FFF2-40B4-BE49-F238E27FC236}">
-                <a16:creationId xmlns:a16="http://schemas.microsoft.com/office/drawing/2014/main" id="{7E75FED4-BA3D-0044-55EA-1518683CD07B}"/>
+                <a16:creationId xmlns:a16="http://schemas.microsoft.com/office/drawing/2014/main" id="{CB826CEC-7668-7AD9-3E10-324C9172442E}"/>
               </a:ext>
             </a:extLst>
           </p:cNvPr>
@@ -4805,17 +4967,46 @@
           <a:lstStyle/>
           <a:p>
             <a:r>
-              <a:rPr lang="ru-RU" dirty="0"/>
-              <a:t>Выводы</a:t>
-            </a:r>
-            <a:endParaRPr lang="en-US" dirty="0"/>
-          </a:p>
-        </p:txBody>
-      </p:sp>
+              <a:rPr lang="en-US" dirty="0"/>
+              <a:t>BASIC, graph_8</a:t>
+            </a:r>
+          </a:p>
+        </p:txBody>
+      </p:sp>
+      <p:pic>
+        <p:nvPicPr>
+          <p:cNvPr id="4" name="Picture 3">
+            <a:extLst>
+              <a:ext uri="{FF2B5EF4-FFF2-40B4-BE49-F238E27FC236}">
+                <a16:creationId xmlns:a16="http://schemas.microsoft.com/office/drawing/2014/main" id="{EDEB1195-F2D7-51CD-474F-D3D6FA475A6E}"/>
+              </a:ext>
+            </a:extLst>
+          </p:cNvPr>
+          <p:cNvPicPr>
+            <a:picLocks noChangeAspect="1"/>
+          </p:cNvPicPr>
+          <p:nvPr/>
+        </p:nvPicPr>
+        <p:blipFill>
+          <a:blip r:embed="rId2"/>
+          <a:stretch>
+            <a:fillRect/>
+          </a:stretch>
+        </p:blipFill>
+        <p:spPr>
+          <a:xfrm>
+            <a:off x="0" y="2469624"/>
+            <a:ext cx="12192000" cy="2790627"/>
+          </a:xfrm>
+          <a:prstGeom prst="rect">
+            <a:avLst/>
+          </a:prstGeom>
+        </p:spPr>
+      </p:pic>
     </p:spTree>
     <p:extLst>
       <p:ext uri="{BB962C8B-B14F-4D97-AF65-F5344CB8AC3E}">
-        <p14:creationId xmlns:p14="http://schemas.microsoft.com/office/powerpoint/2010/main" val="1017558136"/>
+        <p14:creationId xmlns:p14="http://schemas.microsoft.com/office/powerpoint/2010/main" val="1179465604"/>
       </p:ext>
     </p:extLst>
   </p:cSld>

</xml_diff>